<commit_message>
Add scripts to apply geometric style and generate three-surface offers presentation
- Implemented `apply_geometric_style.py` to apply a geometric accent style to AI CoE decks, including title and corner accents.
- Created `build_three_surface_offers.py` to generate a PowerPoint presentation for three packaged offers related to AI surfaces, including detailed offer descriptions and speaker notes.
</commit_message>
<xml_diff>
--- a/AI-CoE-Customer-Pitch.pptx
+++ b/AI-CoE-Customer-Pitch.pptx
@@ -1364,6 +1364,226 @@
           </a:p>
         </p:txBody>
       </p:sp>
+      <p:sp>
+        <p:nvSpPr>
+          <p:cNvPr id="12" name="AICOE_GEO_ACCENT_Right Triangle 11"/>
+          <p:cNvSpPr/>
+          <p:nvPr/>
+        </p:nvSpPr>
+        <p:spPr>
+          <a:xfrm>
+            <a:off x="11369040" y="445770"/>
+            <a:ext cx="822960" cy="822960"/>
+          </a:xfrm>
+          <a:prstGeom prst="rtTriangle">
+            <a:avLst/>
+          </a:prstGeom>
+          <a:solidFill>
+            <a:srgbClr val="0B1F3A"/>
+          </a:solidFill>
+          <a:ln>
+            <a:noFill/>
+          </a:ln>
+          <a:effectLst/>
+        </p:spPr>
+        <p:style>
+          <a:lnRef idx="1">
+            <a:schemeClr val="accent1"/>
+          </a:lnRef>
+          <a:fillRef idx="3">
+            <a:schemeClr val="accent1"/>
+          </a:fillRef>
+          <a:effectRef idx="2">
+            <a:schemeClr val="accent1"/>
+          </a:effectRef>
+          <a:fontRef idx="minor">
+            <a:schemeClr val="lt1"/>
+          </a:fontRef>
+        </p:style>
+        <p:txBody>
+          <a:bodyPr rtlCol="0" anchor="ctr"/>
+          <a:lstStyle/>
+          <a:p>
+            <a:pPr algn="ctr"/>
+          </a:p>
+        </p:txBody>
+      </p:sp>
+      <p:sp>
+        <p:nvSpPr>
+          <p:cNvPr id="13" name="AICOE_GEO_ACCENT_Right Triangle 12"/>
+          <p:cNvSpPr/>
+          <p:nvPr/>
+        </p:nvSpPr>
+        <p:spPr>
+          <a:xfrm rot="10800000">
+            <a:off x="11369040" y="2160270"/>
+            <a:ext cx="822960" cy="822960"/>
+          </a:xfrm>
+          <a:prstGeom prst="rtTriangle">
+            <a:avLst/>
+          </a:prstGeom>
+          <a:solidFill>
+            <a:srgbClr val="50E6FF"/>
+          </a:solidFill>
+          <a:ln>
+            <a:noFill/>
+          </a:ln>
+          <a:effectLst/>
+        </p:spPr>
+        <p:style>
+          <a:lnRef idx="1">
+            <a:schemeClr val="accent1"/>
+          </a:lnRef>
+          <a:fillRef idx="3">
+            <a:schemeClr val="accent1"/>
+          </a:fillRef>
+          <a:effectRef idx="2">
+            <a:schemeClr val="accent1"/>
+          </a:effectRef>
+          <a:fontRef idx="minor">
+            <a:schemeClr val="lt1"/>
+          </a:fontRef>
+        </p:style>
+        <p:txBody>
+          <a:bodyPr rtlCol="0" anchor="ctr"/>
+          <a:lstStyle/>
+          <a:p>
+            <a:pPr algn="ctr"/>
+          </a:p>
+        </p:txBody>
+      </p:sp>
+      <p:sp>
+        <p:nvSpPr>
+          <p:cNvPr id="14" name="AICOE_GEO_ACCENT_Right Triangle 13"/>
+          <p:cNvSpPr/>
+          <p:nvPr/>
+        </p:nvSpPr>
+        <p:spPr>
+          <a:xfrm>
+            <a:off x="11369040" y="3874770"/>
+            <a:ext cx="822960" cy="822960"/>
+          </a:xfrm>
+          <a:prstGeom prst="rtTriangle">
+            <a:avLst/>
+          </a:prstGeom>
+          <a:solidFill>
+            <a:srgbClr val="0067B8"/>
+          </a:solidFill>
+          <a:ln>
+            <a:noFill/>
+          </a:ln>
+          <a:effectLst/>
+        </p:spPr>
+        <p:style>
+          <a:lnRef idx="1">
+            <a:schemeClr val="accent1"/>
+          </a:lnRef>
+          <a:fillRef idx="3">
+            <a:schemeClr val="accent1"/>
+          </a:fillRef>
+          <a:effectRef idx="2">
+            <a:schemeClr val="accent1"/>
+          </a:effectRef>
+          <a:fontRef idx="minor">
+            <a:schemeClr val="lt1"/>
+          </a:fontRef>
+        </p:style>
+        <p:txBody>
+          <a:bodyPr rtlCol="0" anchor="ctr"/>
+          <a:lstStyle/>
+          <a:p>
+            <a:pPr algn="ctr"/>
+          </a:p>
+        </p:txBody>
+      </p:sp>
+      <p:sp>
+        <p:nvSpPr>
+          <p:cNvPr id="15" name="AICOE_GEO_ACCENT_Right Triangle 14"/>
+          <p:cNvSpPr/>
+          <p:nvPr/>
+        </p:nvSpPr>
+        <p:spPr>
+          <a:xfrm rot="5400000">
+            <a:off x="11369040" y="5589270"/>
+            <a:ext cx="822960" cy="822960"/>
+          </a:xfrm>
+          <a:prstGeom prst="rtTriangle">
+            <a:avLst/>
+          </a:prstGeom>
+          <a:solidFill>
+            <a:srgbClr val="50E6FF"/>
+          </a:solidFill>
+          <a:ln>
+            <a:noFill/>
+          </a:ln>
+          <a:effectLst/>
+        </p:spPr>
+        <p:style>
+          <a:lnRef idx="1">
+            <a:schemeClr val="accent1"/>
+          </a:lnRef>
+          <a:fillRef idx="3">
+            <a:schemeClr val="accent1"/>
+          </a:fillRef>
+          <a:effectRef idx="2">
+            <a:schemeClr val="accent1"/>
+          </a:effectRef>
+          <a:fontRef idx="minor">
+            <a:schemeClr val="lt1"/>
+          </a:fontRef>
+        </p:style>
+        <p:txBody>
+          <a:bodyPr rtlCol="0" anchor="ctr"/>
+          <a:lstStyle/>
+          <a:p>
+            <a:pPr algn="ctr"/>
+          </a:p>
+        </p:txBody>
+      </p:sp>
+      <p:sp>
+        <p:nvSpPr>
+          <p:cNvPr id="16" name="AICOE_GEO_ACCENT_Rectangle 15"/>
+          <p:cNvSpPr/>
+          <p:nvPr/>
+        </p:nvSpPr>
+        <p:spPr>
+          <a:xfrm>
+            <a:off x="11295888" y="0"/>
+            <a:ext cx="73152" cy="6858000"/>
+          </a:xfrm>
+          <a:prstGeom prst="rect">
+            <a:avLst/>
+          </a:prstGeom>
+          <a:solidFill>
+            <a:srgbClr val="0B1F3A"/>
+          </a:solidFill>
+          <a:ln>
+            <a:noFill/>
+          </a:ln>
+          <a:effectLst/>
+        </p:spPr>
+        <p:style>
+          <a:lnRef idx="1">
+            <a:schemeClr val="accent1"/>
+          </a:lnRef>
+          <a:fillRef idx="3">
+            <a:schemeClr val="accent1"/>
+          </a:fillRef>
+          <a:effectRef idx="2">
+            <a:schemeClr val="accent1"/>
+          </a:effectRef>
+          <a:fontRef idx="minor">
+            <a:schemeClr val="lt1"/>
+          </a:fontRef>
+        </p:style>
+        <p:txBody>
+          <a:bodyPr rtlCol="0" anchor="ctr"/>
+          <a:lstStyle/>
+          <a:p>
+            <a:pPr algn="ctr"/>
+          </a:p>
+        </p:txBody>
+      </p:sp>
     </p:spTree>
   </p:cSld>
   <p:clrMapOvr>
@@ -2331,6 +2551,94 @@
           </a:p>
         </p:txBody>
       </p:sp>
+      <p:sp>
+        <p:nvSpPr>
+          <p:cNvPr id="28" name="AICOE_GEO_ACCENT_Right Triangle 27"/>
+          <p:cNvSpPr/>
+          <p:nvPr/>
+        </p:nvSpPr>
+        <p:spPr>
+          <a:xfrm rot="5400000">
+            <a:off x="11762232" y="109728"/>
+            <a:ext cx="320040" cy="320040"/>
+          </a:xfrm>
+          <a:prstGeom prst="rtTriangle">
+            <a:avLst/>
+          </a:prstGeom>
+          <a:solidFill>
+            <a:srgbClr val="0B1F3A"/>
+          </a:solidFill>
+          <a:ln>
+            <a:noFill/>
+          </a:ln>
+          <a:effectLst/>
+        </p:spPr>
+        <p:style>
+          <a:lnRef idx="1">
+            <a:schemeClr val="accent1"/>
+          </a:lnRef>
+          <a:fillRef idx="3">
+            <a:schemeClr val="accent1"/>
+          </a:fillRef>
+          <a:effectRef idx="2">
+            <a:schemeClr val="accent1"/>
+          </a:effectRef>
+          <a:fontRef idx="minor">
+            <a:schemeClr val="lt1"/>
+          </a:fontRef>
+        </p:style>
+        <p:txBody>
+          <a:bodyPr rtlCol="0" anchor="ctr"/>
+          <a:lstStyle/>
+          <a:p>
+            <a:pPr algn="ctr"/>
+          </a:p>
+        </p:txBody>
+      </p:sp>
+      <p:sp>
+        <p:nvSpPr>
+          <p:cNvPr id="29" name="AICOE_GEO_ACCENT_Right Triangle 28"/>
+          <p:cNvSpPr/>
+          <p:nvPr/>
+        </p:nvSpPr>
+        <p:spPr>
+          <a:xfrm rot="5400000">
+            <a:off x="11874246" y="109728"/>
+            <a:ext cx="208026" cy="208026"/>
+          </a:xfrm>
+          <a:prstGeom prst="rtTriangle">
+            <a:avLst/>
+          </a:prstGeom>
+          <a:solidFill>
+            <a:srgbClr val="50E6FF"/>
+          </a:solidFill>
+          <a:ln>
+            <a:noFill/>
+          </a:ln>
+          <a:effectLst/>
+        </p:spPr>
+        <p:style>
+          <a:lnRef idx="1">
+            <a:schemeClr val="accent1"/>
+          </a:lnRef>
+          <a:fillRef idx="3">
+            <a:schemeClr val="accent1"/>
+          </a:fillRef>
+          <a:effectRef idx="2">
+            <a:schemeClr val="accent1"/>
+          </a:effectRef>
+          <a:fontRef idx="minor">
+            <a:schemeClr val="lt1"/>
+          </a:fontRef>
+        </p:style>
+        <p:txBody>
+          <a:bodyPr rtlCol="0" anchor="ctr"/>
+          <a:lstStyle/>
+          <a:p>
+            <a:pPr algn="ctr"/>
+          </a:p>
+        </p:txBody>
+      </p:sp>
     </p:spTree>
   </p:cSld>
   <p:clrMapOvr>
@@ -4486,6 +4794,94 @@
           </a:p>
         </p:txBody>
       </p:sp>
+      <p:sp>
+        <p:nvSpPr>
+          <p:cNvPr id="60" name="AICOE_GEO_ACCENT_Right Triangle 59"/>
+          <p:cNvSpPr/>
+          <p:nvPr/>
+        </p:nvSpPr>
+        <p:spPr>
+          <a:xfrm rot="5400000">
+            <a:off x="11762232" y="109728"/>
+            <a:ext cx="320040" cy="320040"/>
+          </a:xfrm>
+          <a:prstGeom prst="rtTriangle">
+            <a:avLst/>
+          </a:prstGeom>
+          <a:solidFill>
+            <a:srgbClr val="0B1F3A"/>
+          </a:solidFill>
+          <a:ln>
+            <a:noFill/>
+          </a:ln>
+          <a:effectLst/>
+        </p:spPr>
+        <p:style>
+          <a:lnRef idx="1">
+            <a:schemeClr val="accent1"/>
+          </a:lnRef>
+          <a:fillRef idx="3">
+            <a:schemeClr val="accent1"/>
+          </a:fillRef>
+          <a:effectRef idx="2">
+            <a:schemeClr val="accent1"/>
+          </a:effectRef>
+          <a:fontRef idx="minor">
+            <a:schemeClr val="lt1"/>
+          </a:fontRef>
+        </p:style>
+        <p:txBody>
+          <a:bodyPr rtlCol="0" anchor="ctr"/>
+          <a:lstStyle/>
+          <a:p>
+            <a:pPr algn="ctr"/>
+          </a:p>
+        </p:txBody>
+      </p:sp>
+      <p:sp>
+        <p:nvSpPr>
+          <p:cNvPr id="61" name="AICOE_GEO_ACCENT_Right Triangle 60"/>
+          <p:cNvSpPr/>
+          <p:nvPr/>
+        </p:nvSpPr>
+        <p:spPr>
+          <a:xfrm rot="5400000">
+            <a:off x="11874246" y="109728"/>
+            <a:ext cx="208026" cy="208026"/>
+          </a:xfrm>
+          <a:prstGeom prst="rtTriangle">
+            <a:avLst/>
+          </a:prstGeom>
+          <a:solidFill>
+            <a:srgbClr val="50E6FF"/>
+          </a:solidFill>
+          <a:ln>
+            <a:noFill/>
+          </a:ln>
+          <a:effectLst/>
+        </p:spPr>
+        <p:style>
+          <a:lnRef idx="1">
+            <a:schemeClr val="accent1"/>
+          </a:lnRef>
+          <a:fillRef idx="3">
+            <a:schemeClr val="accent1"/>
+          </a:fillRef>
+          <a:effectRef idx="2">
+            <a:schemeClr val="accent1"/>
+          </a:effectRef>
+          <a:fontRef idx="minor">
+            <a:schemeClr val="lt1"/>
+          </a:fontRef>
+        </p:style>
+        <p:txBody>
+          <a:bodyPr rtlCol="0" anchor="ctr"/>
+          <a:lstStyle/>
+          <a:p>
+            <a:pPr algn="ctr"/>
+          </a:p>
+        </p:txBody>
+      </p:sp>
     </p:spTree>
   </p:cSld>
   <p:clrMapOvr>
@@ -6430,6 +6826,94 @@
           </a:p>
         </p:txBody>
       </p:sp>
+      <p:sp>
+        <p:nvSpPr>
+          <p:cNvPr id="55" name="AICOE_GEO_ACCENT_Right Triangle 54"/>
+          <p:cNvSpPr/>
+          <p:nvPr/>
+        </p:nvSpPr>
+        <p:spPr>
+          <a:xfrm rot="5400000">
+            <a:off x="11762232" y="109728"/>
+            <a:ext cx="320040" cy="320040"/>
+          </a:xfrm>
+          <a:prstGeom prst="rtTriangle">
+            <a:avLst/>
+          </a:prstGeom>
+          <a:solidFill>
+            <a:srgbClr val="0B1F3A"/>
+          </a:solidFill>
+          <a:ln>
+            <a:noFill/>
+          </a:ln>
+          <a:effectLst/>
+        </p:spPr>
+        <p:style>
+          <a:lnRef idx="1">
+            <a:schemeClr val="accent1"/>
+          </a:lnRef>
+          <a:fillRef idx="3">
+            <a:schemeClr val="accent1"/>
+          </a:fillRef>
+          <a:effectRef idx="2">
+            <a:schemeClr val="accent1"/>
+          </a:effectRef>
+          <a:fontRef idx="minor">
+            <a:schemeClr val="lt1"/>
+          </a:fontRef>
+        </p:style>
+        <p:txBody>
+          <a:bodyPr rtlCol="0" anchor="ctr"/>
+          <a:lstStyle/>
+          <a:p>
+            <a:pPr algn="ctr"/>
+          </a:p>
+        </p:txBody>
+      </p:sp>
+      <p:sp>
+        <p:nvSpPr>
+          <p:cNvPr id="56" name="AICOE_GEO_ACCENT_Right Triangle 55"/>
+          <p:cNvSpPr/>
+          <p:nvPr/>
+        </p:nvSpPr>
+        <p:spPr>
+          <a:xfrm rot="5400000">
+            <a:off x="11874246" y="109728"/>
+            <a:ext cx="208026" cy="208026"/>
+          </a:xfrm>
+          <a:prstGeom prst="rtTriangle">
+            <a:avLst/>
+          </a:prstGeom>
+          <a:solidFill>
+            <a:srgbClr val="50E6FF"/>
+          </a:solidFill>
+          <a:ln>
+            <a:noFill/>
+          </a:ln>
+          <a:effectLst/>
+        </p:spPr>
+        <p:style>
+          <a:lnRef idx="1">
+            <a:schemeClr val="accent1"/>
+          </a:lnRef>
+          <a:fillRef idx="3">
+            <a:schemeClr val="accent1"/>
+          </a:fillRef>
+          <a:effectRef idx="2">
+            <a:schemeClr val="accent1"/>
+          </a:effectRef>
+          <a:fontRef idx="minor">
+            <a:schemeClr val="lt1"/>
+          </a:fontRef>
+        </p:style>
+        <p:txBody>
+          <a:bodyPr rtlCol="0" anchor="ctr"/>
+          <a:lstStyle/>
+          <a:p>
+            <a:pPr algn="ctr"/>
+          </a:p>
+        </p:txBody>
+      </p:sp>
     </p:spTree>
   </p:cSld>
   <p:clrMapOvr>
@@ -8112,6 +8596,94 @@
               <a:t>5 / 5</a:t>
             </a:r>
             <a:endParaRPr lang="en-US" sz="900" dirty="0"/>
+          </a:p>
+        </p:txBody>
+      </p:sp>
+      <p:sp>
+        <p:nvSpPr>
+          <p:cNvPr id="48" name="AICOE_GEO_ACCENT_Right Triangle 47"/>
+          <p:cNvSpPr/>
+          <p:nvPr/>
+        </p:nvSpPr>
+        <p:spPr>
+          <a:xfrm rot="5400000">
+            <a:off x="11762232" y="109728"/>
+            <a:ext cx="320040" cy="320040"/>
+          </a:xfrm>
+          <a:prstGeom prst="rtTriangle">
+            <a:avLst/>
+          </a:prstGeom>
+          <a:solidFill>
+            <a:srgbClr val="0B1F3A"/>
+          </a:solidFill>
+          <a:ln>
+            <a:noFill/>
+          </a:ln>
+          <a:effectLst/>
+        </p:spPr>
+        <p:style>
+          <a:lnRef idx="1">
+            <a:schemeClr val="accent1"/>
+          </a:lnRef>
+          <a:fillRef idx="3">
+            <a:schemeClr val="accent1"/>
+          </a:fillRef>
+          <a:effectRef idx="2">
+            <a:schemeClr val="accent1"/>
+          </a:effectRef>
+          <a:fontRef idx="minor">
+            <a:schemeClr val="lt1"/>
+          </a:fontRef>
+        </p:style>
+        <p:txBody>
+          <a:bodyPr rtlCol="0" anchor="ctr"/>
+          <a:lstStyle/>
+          <a:p>
+            <a:pPr algn="ctr"/>
+          </a:p>
+        </p:txBody>
+      </p:sp>
+      <p:sp>
+        <p:nvSpPr>
+          <p:cNvPr id="49" name="AICOE_GEO_ACCENT_Right Triangle 48"/>
+          <p:cNvSpPr/>
+          <p:nvPr/>
+        </p:nvSpPr>
+        <p:spPr>
+          <a:xfrm rot="5400000">
+            <a:off x="11874246" y="109728"/>
+            <a:ext cx="208026" cy="208026"/>
+          </a:xfrm>
+          <a:prstGeom prst="rtTriangle">
+            <a:avLst/>
+          </a:prstGeom>
+          <a:solidFill>
+            <a:srgbClr val="50E6FF"/>
+          </a:solidFill>
+          <a:ln>
+            <a:noFill/>
+          </a:ln>
+          <a:effectLst/>
+        </p:spPr>
+        <p:style>
+          <a:lnRef idx="1">
+            <a:schemeClr val="accent1"/>
+          </a:lnRef>
+          <a:fillRef idx="3">
+            <a:schemeClr val="accent1"/>
+          </a:fillRef>
+          <a:effectRef idx="2">
+            <a:schemeClr val="accent1"/>
+          </a:effectRef>
+          <a:fontRef idx="minor">
+            <a:schemeClr val="lt1"/>
+          </a:fontRef>
+        </p:style>
+        <p:txBody>
+          <a:bodyPr rtlCol="0" anchor="ctr"/>
+          <a:lstStyle/>
+          <a:p>
+            <a:pPr algn="ctr"/>
           </a:p>
         </p:txBody>
       </p:sp>

</xml_diff>